<commit_message>
Update defense deck scenario chart
</commit_message>
<xml_diff>
--- a/Professional_Industry_Defense_Deck.pptx
+++ b/Professional_Industry_Defense_Deck.pptx
@@ -2,22 +2,22 @@
 <file path=ppt/presentation.xml><?xml version="1.0" encoding="utf-8"?>
 <p:presentation xmlns:p="http://schemas.openxmlformats.org/presentationml/2006/main">
   <p:sldMasterIdLst>
-    <p:sldMasterId xmlns:r="http://schemas.openxmlformats.org/officeDocument/2006/relationships" id="2147483648" r:id="Ref1ffd6bd8144dd8"/>
+    <p:sldMasterId xmlns:r="http://schemas.openxmlformats.org/officeDocument/2006/relationships" id="2147483648" r:id="R9e20dd5c6866455d"/>
   </p:sldMasterIdLst>
   <p:notesMasterIdLst>
-    <p:notesMasterId xmlns:r="http://schemas.openxmlformats.org/officeDocument/2006/relationships" r:id="R82a40c0455af4e4b"/>
+    <p:notesMasterId xmlns:r="http://schemas.openxmlformats.org/officeDocument/2006/relationships" r:id="Rd465ef786fcd4e84"/>
   </p:notesMasterIdLst>
   <p:sldIdLst>
-    <p:sldId xmlns:r="http://schemas.openxmlformats.org/officeDocument/2006/relationships" id="256" r:id="R178883368839491a"/>
-    <p:sldId xmlns:r="http://schemas.openxmlformats.org/officeDocument/2006/relationships" id="257" r:id="R55c667b8dc814d34"/>
-    <p:sldId xmlns:r="http://schemas.openxmlformats.org/officeDocument/2006/relationships" id="258" r:id="Rd7807477b3d3441e"/>
-    <p:sldId xmlns:r="http://schemas.openxmlformats.org/officeDocument/2006/relationships" id="259" r:id="R7b84488945fa4bf5"/>
-    <p:sldId xmlns:r="http://schemas.openxmlformats.org/officeDocument/2006/relationships" id="260" r:id="R15a63714ec264de7"/>
-    <p:sldId xmlns:r="http://schemas.openxmlformats.org/officeDocument/2006/relationships" id="261" r:id="Rb0e91aec77d0435c"/>
-    <p:sldId xmlns:r="http://schemas.openxmlformats.org/officeDocument/2006/relationships" id="262" r:id="R356a98eaa5eb446f"/>
-    <p:sldId xmlns:r="http://schemas.openxmlformats.org/officeDocument/2006/relationships" id="263" r:id="R748da045237f41c9"/>
-    <p:sldId xmlns:r="http://schemas.openxmlformats.org/officeDocument/2006/relationships" id="264" r:id="R075853c88a73452d"/>
-    <p:sldId xmlns:r="http://schemas.openxmlformats.org/officeDocument/2006/relationships" id="265" r:id="R0a080a93d6334b90"/>
+    <p:sldId xmlns:r="http://schemas.openxmlformats.org/officeDocument/2006/relationships" id="256" r:id="Rea9de7aaea0c44fd"/>
+    <p:sldId xmlns:r="http://schemas.openxmlformats.org/officeDocument/2006/relationships" id="257" r:id="Rbf3550db516e4ac0"/>
+    <p:sldId xmlns:r="http://schemas.openxmlformats.org/officeDocument/2006/relationships" id="258" r:id="R044e3bfa27e94ffe"/>
+    <p:sldId xmlns:r="http://schemas.openxmlformats.org/officeDocument/2006/relationships" id="259" r:id="Ra9f89dfdfeb44dea"/>
+    <p:sldId xmlns:r="http://schemas.openxmlformats.org/officeDocument/2006/relationships" id="260" r:id="R217e18f710be471d"/>
+    <p:sldId xmlns:r="http://schemas.openxmlformats.org/officeDocument/2006/relationships" id="261" r:id="R4645f203d0c046ae"/>
+    <p:sldId xmlns:r="http://schemas.openxmlformats.org/officeDocument/2006/relationships" id="262" r:id="R6dbfdfb6045440a7"/>
+    <p:sldId xmlns:r="http://schemas.openxmlformats.org/officeDocument/2006/relationships" id="263" r:id="R476f5565196243ac"/>
+    <p:sldId xmlns:r="http://schemas.openxmlformats.org/officeDocument/2006/relationships" id="264" r:id="Rc2ea4f331d5e4469"/>
+    <p:sldId xmlns:r="http://schemas.openxmlformats.org/officeDocument/2006/relationships" id="265" r:id="R66b9fa1e14ff48de"/>
   </p:sldIdLst>
   <p:sldSz cx="12192000" cy="6858000"/>
   <p:notesSz cx="6858000" cy="9144000"/>
@@ -1344,7 +1344,7 @@
   </p:cSld>
   <p:clrMap bg1="lt1" tx1="dk1" bg2="lt2" tx2="dk2" accent1="accent1" accent2="accent2" accent3="accent3" accent4="accent4" accent5="accent5" accent6="accent6" hlink="hlink" folHlink="folHlink"/>
   <p:sldLayoutIdLst>
-    <p:sldLayoutId xmlns:r="http://schemas.openxmlformats.org/officeDocument/2006/relationships" id="2147483649" r:id="R27c5d0abf26d4b1e"/>
+    <p:sldLayoutId xmlns:r="http://schemas.openxmlformats.org/officeDocument/2006/relationships" id="2147483649" r:id="R6488c0b323ac4901"/>
   </p:sldLayoutIdLst>
   <p:txStyles>
     <p:titleStyle>
@@ -1926,13 +1926,13 @@
                 <c:v>12</c:v>
               </c:pt>
               <c:pt idx="1">
-                <c:v>44</c:v>
+                <c:v>62</c:v>
               </c:pt>
               <c:pt idx="2">
-                <c:v>18</c:v>
+                <c:v>34</c:v>
               </c:pt>
               <c:pt idx="3">
-                <c:v>96</c:v>
+                <c:v>98</c:v>
               </c:pt>
             </c:numLit>
           </c:val>
@@ -2062,7 +2062,7 @@
           <p:cNvPr id="1" name="">
             <a:extLst xmlns:a="http://schemas.openxmlformats.org/drawingml/2006/main">
               <a:ext uri="{FF2B5EF4-FFF2-40B4-BE49-F238E27FC236}">
-                <a16:creationId xmlns:a16="http://schemas.microsoft.com/office/drawing/2014/main" id="{12DDEEAC-FAB6-4E04-BB99-611B59425FBC}"/>
+                <a16:creationId xmlns:a16="http://schemas.microsoft.com/office/drawing/2014/main" id="{E3A06049-73B4-44AA-8B08-61E8D428C7D8}"/>
               </a:ext>
             </a:extLst>
           </p:cNvPr>
@@ -2093,7 +2093,7 @@
           <p:cNvPr id="2" name="">
             <a:extLst xmlns:a="http://schemas.openxmlformats.org/drawingml/2006/main">
               <a:ext uri="{FF2B5EF4-FFF2-40B4-BE49-F238E27FC236}">
-                <a16:creationId xmlns:a16="http://schemas.microsoft.com/office/drawing/2014/main" id="{4DA80CE4-E6A3-46BD-8951-201B5AAD2A38}"/>
+                <a16:creationId xmlns:a16="http://schemas.microsoft.com/office/drawing/2014/main" id="{79C050BC-AF74-4DB7-9659-46F6C04C905E}"/>
               </a:ext>
             </a:extLst>
           </p:cNvPr>
@@ -2143,7 +2143,7 @@
           <p:cNvPr id="3" name="">
             <a:extLst xmlns:a="http://schemas.openxmlformats.org/drawingml/2006/main">
               <a:ext uri="{FF2B5EF4-FFF2-40B4-BE49-F238E27FC236}">
-                <a16:creationId xmlns:a16="http://schemas.microsoft.com/office/drawing/2014/main" id="{3BD29A3B-E4BE-444E-B8BB-66F6723BD752}"/>
+                <a16:creationId xmlns:a16="http://schemas.microsoft.com/office/drawing/2014/main" id="{65E87004-F2D2-4EA4-BF67-0631089CDF51}"/>
               </a:ext>
             </a:extLst>
           </p:cNvPr>
@@ -2193,7 +2193,7 @@
           <p:cNvPr id="4" name="">
             <a:extLst xmlns:a="http://schemas.openxmlformats.org/drawingml/2006/main">
               <a:ext uri="{FF2B5EF4-FFF2-40B4-BE49-F238E27FC236}">
-                <a16:creationId xmlns:a16="http://schemas.microsoft.com/office/drawing/2014/main" id="{972F08A8-1A36-4AF0-8F7D-FDF3439ACDFE}"/>
+                <a16:creationId xmlns:a16="http://schemas.microsoft.com/office/drawing/2014/main" id="{D0E313DC-C4D7-4EAA-96BB-F7CC4D89DB38}"/>
               </a:ext>
             </a:extLst>
           </p:cNvPr>
@@ -2243,7 +2243,7 @@
           <p:cNvPr id="5" name="">
             <a:extLst xmlns:a="http://schemas.openxmlformats.org/drawingml/2006/main">
               <a:ext uri="{FF2B5EF4-FFF2-40B4-BE49-F238E27FC236}">
-                <a16:creationId xmlns:a16="http://schemas.microsoft.com/office/drawing/2014/main" id="{742A478F-31B0-4578-B50F-81EAEE8E95BF}"/>
+                <a16:creationId xmlns:a16="http://schemas.microsoft.com/office/drawing/2014/main" id="{0127CE56-6D11-4DAB-A4F2-74EEF61825AA}"/>
               </a:ext>
             </a:extLst>
           </p:cNvPr>
@@ -2293,7 +2293,7 @@
           <p:cNvPr id="6" name="">
             <a:extLst xmlns:a="http://schemas.openxmlformats.org/drawingml/2006/main">
               <a:ext uri="{FF2B5EF4-FFF2-40B4-BE49-F238E27FC236}">
-                <a16:creationId xmlns:a16="http://schemas.microsoft.com/office/drawing/2014/main" id="{03FC19A3-D203-41E9-AE21-5507B43C7272}"/>
+                <a16:creationId xmlns:a16="http://schemas.microsoft.com/office/drawing/2014/main" id="{BD98C586-7DB0-456B-89BE-0EE2AD3C029E}"/>
               </a:ext>
             </a:extLst>
           </p:cNvPr>
@@ -2324,7 +2324,7 @@
           <p:cNvPr id="7" name="">
             <a:extLst xmlns:a="http://schemas.openxmlformats.org/drawingml/2006/main">
               <a:ext uri="{FF2B5EF4-FFF2-40B4-BE49-F238E27FC236}">
-                <a16:creationId xmlns:a16="http://schemas.microsoft.com/office/drawing/2014/main" id="{8CC2E56A-8D29-4158-951B-4FB8EE7BEFC7}"/>
+                <a16:creationId xmlns:a16="http://schemas.microsoft.com/office/drawing/2014/main" id="{D62035CF-4CF2-4183-BF02-ADBAD14AFB4A}"/>
               </a:ext>
             </a:extLst>
           </p:cNvPr>
@@ -2391,7 +2391,7 @@
           <p:cNvPr id="8" name="">
             <a:extLst xmlns:a="http://schemas.openxmlformats.org/drawingml/2006/main">
               <a:ext uri="{FF2B5EF4-FFF2-40B4-BE49-F238E27FC236}">
-                <a16:creationId xmlns:a16="http://schemas.microsoft.com/office/drawing/2014/main" id="{5B25597F-5721-4F39-B52A-374BF1ED57FC}"/>
+                <a16:creationId xmlns:a16="http://schemas.microsoft.com/office/drawing/2014/main" id="{1AB0BE6F-C7AB-419D-94EC-C4720825BAAC}"/>
               </a:ext>
             </a:extLst>
           </p:cNvPr>
@@ -2441,7 +2441,7 @@
           <p:cNvPr id="9" name="">
             <a:extLst xmlns:a="http://schemas.openxmlformats.org/drawingml/2006/main">
               <a:ext uri="{FF2B5EF4-FFF2-40B4-BE49-F238E27FC236}">
-                <a16:creationId xmlns:a16="http://schemas.microsoft.com/office/drawing/2014/main" id="{BA5A6081-EBB5-44E5-9E34-DAE24577D66E}"/>
+                <a16:creationId xmlns:a16="http://schemas.microsoft.com/office/drawing/2014/main" id="{35692765-BC21-42DA-B1A3-6850C6388709}"/>
               </a:ext>
             </a:extLst>
           </p:cNvPr>
@@ -2489,7 +2489,7 @@
     </p:spTree>
     <p:extLst>
       <p:ext uri="{BB962C8B-B14F-4D97-AF65-F5344CB8AC3E}">
-        <p14:creationId xmlns:p14="http://schemas.microsoft.com/office/powerpoint/2010/main" val="1523911314"/>
+        <p14:creationId xmlns:p14="http://schemas.microsoft.com/office/powerpoint/2010/main" val="1945947655"/>
       </p:ext>
     </p:extLst>
   </p:cSld>
@@ -2513,7 +2513,7 @@
           <p:cNvPr id="1" name="">
             <a:extLst xmlns:a="http://schemas.openxmlformats.org/drawingml/2006/main">
               <a:ext uri="{FF2B5EF4-FFF2-40B4-BE49-F238E27FC236}">
-                <a16:creationId xmlns:a16="http://schemas.microsoft.com/office/drawing/2014/main" id="{1841E0A8-B317-4A78-8F58-EF417E03370D}"/>
+                <a16:creationId xmlns:a16="http://schemas.microsoft.com/office/drawing/2014/main" id="{1D8DC459-B031-4CED-A0AB-6F1569749954}"/>
               </a:ext>
             </a:extLst>
           </p:cNvPr>
@@ -2563,7 +2563,7 @@
           <p:cNvPr id="2" name="">
             <a:extLst xmlns:a="http://schemas.openxmlformats.org/drawingml/2006/main">
               <a:ext uri="{FF2B5EF4-FFF2-40B4-BE49-F238E27FC236}">
-                <a16:creationId xmlns:a16="http://schemas.microsoft.com/office/drawing/2014/main" id="{011ABE1E-9B35-4E15-B431-9B16CB82DC2C}"/>
+                <a16:creationId xmlns:a16="http://schemas.microsoft.com/office/drawing/2014/main" id="{F1944382-C40C-4827-9C54-6E84BBE255C6}"/>
               </a:ext>
             </a:extLst>
           </p:cNvPr>
@@ -2613,7 +2613,7 @@
           <p:cNvPr id="3" name="">
             <a:extLst xmlns:a="http://schemas.openxmlformats.org/drawingml/2006/main">
               <a:ext uri="{FF2B5EF4-FFF2-40B4-BE49-F238E27FC236}">
-                <a16:creationId xmlns:a16="http://schemas.microsoft.com/office/drawing/2014/main" id="{9C4677F0-EFFC-4D45-9E0E-14A834DD92EA}"/>
+                <a16:creationId xmlns:a16="http://schemas.microsoft.com/office/drawing/2014/main" id="{5E6451B9-5339-4D4C-81D0-2AB036CE9B5B}"/>
               </a:ext>
             </a:extLst>
           </p:cNvPr>
@@ -2646,7 +2646,7 @@
           <p:cNvPr id="4" name="">
             <a:extLst xmlns:a="http://schemas.openxmlformats.org/drawingml/2006/main">
               <a:ext uri="{FF2B5EF4-FFF2-40B4-BE49-F238E27FC236}">
-                <a16:creationId xmlns:a16="http://schemas.microsoft.com/office/drawing/2014/main" id="{BF6152C5-1682-4705-84B8-69C72A7FA401}"/>
+                <a16:creationId xmlns:a16="http://schemas.microsoft.com/office/drawing/2014/main" id="{B32494BC-5BB0-4550-83C8-B0E50A9E59A0}"/>
               </a:ext>
             </a:extLst>
           </p:cNvPr>
@@ -2848,7 +2848,7 @@
           <p:cNvPr id="6" name="">
             <a:extLst xmlns:a="http://schemas.openxmlformats.org/drawingml/2006/main">
               <a:ext uri="{FF2B5EF4-FFF2-40B4-BE49-F238E27FC236}">
-                <a16:creationId xmlns:a16="http://schemas.microsoft.com/office/drawing/2014/main" id="{6CBC5D29-3C8D-4761-9491-5D358A523487}"/>
+                <a16:creationId xmlns:a16="http://schemas.microsoft.com/office/drawing/2014/main" id="{6D55740F-557A-4698-8D16-76385024CFA3}"/>
               </a:ext>
             </a:extLst>
           </p:cNvPr>
@@ -2898,7 +2898,7 @@
           <p:cNvPr id="7" name="">
             <a:extLst xmlns:a="http://schemas.openxmlformats.org/drawingml/2006/main">
               <a:ext uri="{FF2B5EF4-FFF2-40B4-BE49-F238E27FC236}">
-                <a16:creationId xmlns:a16="http://schemas.microsoft.com/office/drawing/2014/main" id="{6C42208D-AB09-4D8A-9792-8776438E1FC6}"/>
+                <a16:creationId xmlns:a16="http://schemas.microsoft.com/office/drawing/2014/main" id="{5AF5CD55-E9AB-4C91-ACEE-5FEE78115C03}"/>
               </a:ext>
             </a:extLst>
           </p:cNvPr>
@@ -2948,7 +2948,7 @@
           <p:cNvPr id="8" name="">
             <a:extLst xmlns:a="http://schemas.openxmlformats.org/drawingml/2006/main">
               <a:ext uri="{FF2B5EF4-FFF2-40B4-BE49-F238E27FC236}">
-                <a16:creationId xmlns:a16="http://schemas.microsoft.com/office/drawing/2014/main" id="{8C759E38-2E8D-475C-98A2-B67F094BCC40}"/>
+                <a16:creationId xmlns:a16="http://schemas.microsoft.com/office/drawing/2014/main" id="{51693C72-B77F-4ECB-991B-256E74ED20EF}"/>
               </a:ext>
             </a:extLst>
           </p:cNvPr>
@@ -2996,7 +2996,7 @@
     </p:spTree>
     <p:extLst>
       <p:ext uri="{BB962C8B-B14F-4D97-AF65-F5344CB8AC3E}">
-        <p14:creationId xmlns:p14="http://schemas.microsoft.com/office/powerpoint/2010/main" val="703720465"/>
+        <p14:creationId xmlns:p14="http://schemas.microsoft.com/office/powerpoint/2010/main" val="327183198"/>
       </p:ext>
     </p:extLst>
   </p:cSld>
@@ -3020,7 +3020,7 @@
           <p:cNvPr id="1" name="">
             <a:extLst xmlns:a="http://schemas.openxmlformats.org/drawingml/2006/main">
               <a:ext uri="{FF2B5EF4-FFF2-40B4-BE49-F238E27FC236}">
-                <a16:creationId xmlns:a16="http://schemas.microsoft.com/office/drawing/2014/main" id="{59D0FB65-1AA4-40B8-A025-4E6647594471}"/>
+                <a16:creationId xmlns:a16="http://schemas.microsoft.com/office/drawing/2014/main" id="{0A5C9736-35D3-4D43-8D1F-66701C396735}"/>
               </a:ext>
             </a:extLst>
           </p:cNvPr>
@@ -3070,7 +3070,7 @@
           <p:cNvPr id="2" name="">
             <a:extLst xmlns:a="http://schemas.openxmlformats.org/drawingml/2006/main">
               <a:ext uri="{FF2B5EF4-FFF2-40B4-BE49-F238E27FC236}">
-                <a16:creationId xmlns:a16="http://schemas.microsoft.com/office/drawing/2014/main" id="{DF07E5B4-1320-43A8-844D-FB493EA2C1EC}"/>
+                <a16:creationId xmlns:a16="http://schemas.microsoft.com/office/drawing/2014/main" id="{A9BA5200-663C-48DA-A934-FC5040265352}"/>
               </a:ext>
             </a:extLst>
           </p:cNvPr>
@@ -3120,7 +3120,7 @@
           <p:cNvPr id="3" name="">
             <a:extLst xmlns:a="http://schemas.openxmlformats.org/drawingml/2006/main">
               <a:ext uri="{FF2B5EF4-FFF2-40B4-BE49-F238E27FC236}">
-                <a16:creationId xmlns:a16="http://schemas.microsoft.com/office/drawing/2014/main" id="{DC2FD437-A102-43A2-A00F-3DFCDE30D541}"/>
+                <a16:creationId xmlns:a16="http://schemas.microsoft.com/office/drawing/2014/main" id="{E6DBD4E6-BB3D-43F6-AF4D-A5EE65DF2840}"/>
               </a:ext>
             </a:extLst>
           </p:cNvPr>
@@ -3153,7 +3153,7 @@
           <p:cNvPr id="4" name="">
             <a:extLst xmlns:a="http://schemas.openxmlformats.org/drawingml/2006/main">
               <a:ext uri="{FF2B5EF4-FFF2-40B4-BE49-F238E27FC236}">
-                <a16:creationId xmlns:a16="http://schemas.microsoft.com/office/drawing/2014/main" id="{1395156F-EF68-4EAC-878D-D8AFB13ADB90}"/>
+                <a16:creationId xmlns:a16="http://schemas.microsoft.com/office/drawing/2014/main" id="{2141A2B6-0AEE-4DB4-945A-7E13365D280C}"/>
               </a:ext>
             </a:extLst>
           </p:cNvPr>
@@ -3203,7 +3203,7 @@
           <p:cNvPr id="5" name="">
             <a:extLst xmlns:a="http://schemas.openxmlformats.org/drawingml/2006/main">
               <a:ext uri="{FF2B5EF4-FFF2-40B4-BE49-F238E27FC236}">
-                <a16:creationId xmlns:a16="http://schemas.microsoft.com/office/drawing/2014/main" id="{6CF3C4D2-8F86-48DF-8174-3442902A1257}"/>
+                <a16:creationId xmlns:a16="http://schemas.microsoft.com/office/drawing/2014/main" id="{D06F1344-5D70-4D60-9257-5E937D9FD99D}"/>
               </a:ext>
             </a:extLst>
           </p:cNvPr>
@@ -3304,7 +3304,7 @@
           <p:cNvPr id="6" name="">
             <a:extLst xmlns:a="http://schemas.openxmlformats.org/drawingml/2006/main">
               <a:ext uri="{FF2B5EF4-FFF2-40B4-BE49-F238E27FC236}">
-                <a16:creationId xmlns:a16="http://schemas.microsoft.com/office/drawing/2014/main" id="{CC07F58C-8C57-479D-9384-C2981E93CAC1}"/>
+                <a16:creationId xmlns:a16="http://schemas.microsoft.com/office/drawing/2014/main" id="{F1206153-2D42-480E-AF42-4365433BCB94}"/>
               </a:ext>
             </a:extLst>
           </p:cNvPr>
@@ -3335,7 +3335,7 @@
           <p:cNvPr id="7" name="">
             <a:extLst xmlns:a="http://schemas.openxmlformats.org/drawingml/2006/main">
               <a:ext uri="{FF2B5EF4-FFF2-40B4-BE49-F238E27FC236}">
-                <a16:creationId xmlns:a16="http://schemas.microsoft.com/office/drawing/2014/main" id="{57984DAB-3299-4B6E-B6D3-08601335616D}"/>
+                <a16:creationId xmlns:a16="http://schemas.microsoft.com/office/drawing/2014/main" id="{1E84A2CC-DE27-4CDA-B554-44C32BADA842}"/>
               </a:ext>
             </a:extLst>
           </p:cNvPr>
@@ -3385,7 +3385,7 @@
           <p:cNvPr id="8" name="">
             <a:extLst xmlns:a="http://schemas.openxmlformats.org/drawingml/2006/main">
               <a:ext uri="{FF2B5EF4-FFF2-40B4-BE49-F238E27FC236}">
-                <a16:creationId xmlns:a16="http://schemas.microsoft.com/office/drawing/2014/main" id="{B1181297-E4AC-4E2A-8055-9D96B11FFCF3}"/>
+                <a16:creationId xmlns:a16="http://schemas.microsoft.com/office/drawing/2014/main" id="{14AD7F42-FCD2-4CDE-9770-7493113040F4}"/>
               </a:ext>
             </a:extLst>
           </p:cNvPr>
@@ -3435,7 +3435,7 @@
           <p:cNvPr id="9" name="">
             <a:extLst xmlns:a="http://schemas.openxmlformats.org/drawingml/2006/main">
               <a:ext uri="{FF2B5EF4-FFF2-40B4-BE49-F238E27FC236}">
-                <a16:creationId xmlns:a16="http://schemas.microsoft.com/office/drawing/2014/main" id="{C54CB70B-0E07-4FB4-804C-D44CF225692A}"/>
+                <a16:creationId xmlns:a16="http://schemas.microsoft.com/office/drawing/2014/main" id="{B23517B5-4086-416F-8AC2-C2E1C181446D}"/>
               </a:ext>
             </a:extLst>
           </p:cNvPr>
@@ -3466,7 +3466,7 @@
           <p:cNvPr id="10" name="">
             <a:extLst xmlns:a="http://schemas.openxmlformats.org/drawingml/2006/main">
               <a:ext uri="{FF2B5EF4-FFF2-40B4-BE49-F238E27FC236}">
-                <a16:creationId xmlns:a16="http://schemas.microsoft.com/office/drawing/2014/main" id="{4849B240-4D40-421A-BC4E-67D52001C78C}"/>
+                <a16:creationId xmlns:a16="http://schemas.microsoft.com/office/drawing/2014/main" id="{E7F04255-3970-4DA8-AC62-184111292517}"/>
               </a:ext>
             </a:extLst>
           </p:cNvPr>
@@ -3516,7 +3516,7 @@
           <p:cNvPr id="11" name="">
             <a:extLst xmlns:a="http://schemas.openxmlformats.org/drawingml/2006/main">
               <a:ext uri="{FF2B5EF4-FFF2-40B4-BE49-F238E27FC236}">
-                <a16:creationId xmlns:a16="http://schemas.microsoft.com/office/drawing/2014/main" id="{0A322212-6193-4E48-B805-077B05EFB5FB}"/>
+                <a16:creationId xmlns:a16="http://schemas.microsoft.com/office/drawing/2014/main" id="{251690FA-C678-4C4C-A041-88E63F21BA42}"/>
               </a:ext>
             </a:extLst>
           </p:cNvPr>
@@ -3566,7 +3566,7 @@
           <p:cNvPr id="12" name="">
             <a:extLst xmlns:a="http://schemas.openxmlformats.org/drawingml/2006/main">
               <a:ext uri="{FF2B5EF4-FFF2-40B4-BE49-F238E27FC236}">
-                <a16:creationId xmlns:a16="http://schemas.microsoft.com/office/drawing/2014/main" id="{00BEE05E-0A83-4867-BBD3-0719B960E755}"/>
+                <a16:creationId xmlns:a16="http://schemas.microsoft.com/office/drawing/2014/main" id="{044E03A4-18C4-408A-BEAC-1389E24F0B0F}"/>
               </a:ext>
             </a:extLst>
           </p:cNvPr>
@@ -3597,7 +3597,7 @@
           <p:cNvPr id="13" name="">
             <a:extLst xmlns:a="http://schemas.openxmlformats.org/drawingml/2006/main">
               <a:ext uri="{FF2B5EF4-FFF2-40B4-BE49-F238E27FC236}">
-                <a16:creationId xmlns:a16="http://schemas.microsoft.com/office/drawing/2014/main" id="{7D52E7E2-5C64-46E9-9FEF-E1AF8A44DA01}"/>
+                <a16:creationId xmlns:a16="http://schemas.microsoft.com/office/drawing/2014/main" id="{1828E574-C198-4EBB-9030-90A71933DC46}"/>
               </a:ext>
             </a:extLst>
           </p:cNvPr>
@@ -3647,7 +3647,7 @@
           <p:cNvPr id="14" name="">
             <a:extLst xmlns:a="http://schemas.openxmlformats.org/drawingml/2006/main">
               <a:ext uri="{FF2B5EF4-FFF2-40B4-BE49-F238E27FC236}">
-                <a16:creationId xmlns:a16="http://schemas.microsoft.com/office/drawing/2014/main" id="{E3FCA7B6-5BBA-4BF6-A441-83D791BD6C65}"/>
+                <a16:creationId xmlns:a16="http://schemas.microsoft.com/office/drawing/2014/main" id="{88E0572F-8D65-409C-98DB-DEFBD6F353F6}"/>
               </a:ext>
             </a:extLst>
           </p:cNvPr>
@@ -3697,7 +3697,7 @@
           <p:cNvPr id="15" name="">
             <a:extLst xmlns:a="http://schemas.openxmlformats.org/drawingml/2006/main">
               <a:ext uri="{FF2B5EF4-FFF2-40B4-BE49-F238E27FC236}">
-                <a16:creationId xmlns:a16="http://schemas.microsoft.com/office/drawing/2014/main" id="{017749DF-0A09-4D69-873D-3E9240CD34CD}"/>
+                <a16:creationId xmlns:a16="http://schemas.microsoft.com/office/drawing/2014/main" id="{369D74BB-2B43-4E97-AF6A-603F74D0FCBE}"/>
               </a:ext>
             </a:extLst>
           </p:cNvPr>
@@ -3747,7 +3747,7 @@
           <p:cNvPr id="16" name="">
             <a:extLst xmlns:a="http://schemas.openxmlformats.org/drawingml/2006/main">
               <a:ext uri="{FF2B5EF4-FFF2-40B4-BE49-F238E27FC236}">
-                <a16:creationId xmlns:a16="http://schemas.microsoft.com/office/drawing/2014/main" id="{5DB8D4E3-EF94-4D3F-9520-F8174BAD956F}"/>
+                <a16:creationId xmlns:a16="http://schemas.microsoft.com/office/drawing/2014/main" id="{809832C1-2445-4D2B-BF91-4B08EBD65334}"/>
               </a:ext>
             </a:extLst>
           </p:cNvPr>
@@ -3795,7 +3795,7 @@
     </p:spTree>
     <p:extLst>
       <p:ext uri="{BB962C8B-B14F-4D97-AF65-F5344CB8AC3E}">
-        <p14:creationId xmlns:p14="http://schemas.microsoft.com/office/powerpoint/2010/main" val="493061476"/>
+        <p14:creationId xmlns:p14="http://schemas.microsoft.com/office/powerpoint/2010/main" val="1374159324"/>
       </p:ext>
     </p:extLst>
   </p:cSld>
@@ -3819,7 +3819,7 @@
           <p:cNvPr id="1" name="">
             <a:extLst xmlns:a="http://schemas.openxmlformats.org/drawingml/2006/main">
               <a:ext uri="{FF2B5EF4-FFF2-40B4-BE49-F238E27FC236}">
-                <a16:creationId xmlns:a16="http://schemas.microsoft.com/office/drawing/2014/main" id="{E64B404B-54A9-4922-B767-72B7D0A5FE23}"/>
+                <a16:creationId xmlns:a16="http://schemas.microsoft.com/office/drawing/2014/main" id="{104DB3F8-0FA3-44E9-9DC9-810921AA0226}"/>
               </a:ext>
             </a:extLst>
           </p:cNvPr>
@@ -3869,7 +3869,7 @@
           <p:cNvPr id="2" name="">
             <a:extLst xmlns:a="http://schemas.openxmlformats.org/drawingml/2006/main">
               <a:ext uri="{FF2B5EF4-FFF2-40B4-BE49-F238E27FC236}">
-                <a16:creationId xmlns:a16="http://schemas.microsoft.com/office/drawing/2014/main" id="{C6D02BA7-C0A3-42D8-B844-02BC8160EA81}"/>
+                <a16:creationId xmlns:a16="http://schemas.microsoft.com/office/drawing/2014/main" id="{74F36D14-B5F8-4BBC-9F73-7C6FB10238C3}"/>
               </a:ext>
             </a:extLst>
           </p:cNvPr>
@@ -3919,7 +3919,7 @@
           <p:cNvPr id="3" name="">
             <a:extLst xmlns:a="http://schemas.openxmlformats.org/drawingml/2006/main">
               <a:ext uri="{FF2B5EF4-FFF2-40B4-BE49-F238E27FC236}">
-                <a16:creationId xmlns:a16="http://schemas.microsoft.com/office/drawing/2014/main" id="{786A2DA9-A78F-44FE-9AAF-C838F28A652F}"/>
+                <a16:creationId xmlns:a16="http://schemas.microsoft.com/office/drawing/2014/main" id="{577C8452-0079-4559-A62D-98D56A9E574B}"/>
               </a:ext>
             </a:extLst>
           </p:cNvPr>
@@ -3952,7 +3952,7 @@
           <p:cNvPr id="4" name="">
             <a:extLst xmlns:a="http://schemas.openxmlformats.org/drawingml/2006/main">
               <a:ext uri="{FF2B5EF4-FFF2-40B4-BE49-F238E27FC236}">
-                <a16:creationId xmlns:a16="http://schemas.microsoft.com/office/drawing/2014/main" id="{17651441-0A50-480F-B931-1B4F407B3B15}"/>
+                <a16:creationId xmlns:a16="http://schemas.microsoft.com/office/drawing/2014/main" id="{9697BF34-4E92-401F-8A17-023F0B8A0F75}"/>
               </a:ext>
             </a:extLst>
           </p:cNvPr>
@@ -3983,7 +3983,7 @@
           <p:cNvPr id="5" name="">
             <a:extLst xmlns:a="http://schemas.openxmlformats.org/drawingml/2006/main">
               <a:ext uri="{FF2B5EF4-FFF2-40B4-BE49-F238E27FC236}">
-                <a16:creationId xmlns:a16="http://schemas.microsoft.com/office/drawing/2014/main" id="{DFCD4CDC-86B1-42BD-ABFE-6E382A695803}"/>
+                <a16:creationId xmlns:a16="http://schemas.microsoft.com/office/drawing/2014/main" id="{096FDFDF-B631-43B8-B59D-5B93E0F5B8C1}"/>
               </a:ext>
             </a:extLst>
           </p:cNvPr>
@@ -4033,7 +4033,7 @@
           <p:cNvPr id="6" name="">
             <a:extLst xmlns:a="http://schemas.openxmlformats.org/drawingml/2006/main">
               <a:ext uri="{FF2B5EF4-FFF2-40B4-BE49-F238E27FC236}">
-                <a16:creationId xmlns:a16="http://schemas.microsoft.com/office/drawing/2014/main" id="{7FEEC6C8-B113-4F90-AB72-44D36CDABB15}"/>
+                <a16:creationId xmlns:a16="http://schemas.microsoft.com/office/drawing/2014/main" id="{C8315C57-A930-463F-A0E8-C7EE4084B8E4}"/>
               </a:ext>
             </a:extLst>
           </p:cNvPr>
@@ -4083,7 +4083,7 @@
           <p:cNvPr id="7" name="">
             <a:extLst xmlns:a="http://schemas.openxmlformats.org/drawingml/2006/main">
               <a:ext uri="{FF2B5EF4-FFF2-40B4-BE49-F238E27FC236}">
-                <a16:creationId xmlns:a16="http://schemas.microsoft.com/office/drawing/2014/main" id="{599C1BE8-B830-43B9-B0DE-E24A3CE7A429}"/>
+                <a16:creationId xmlns:a16="http://schemas.microsoft.com/office/drawing/2014/main" id="{C2F34EA5-9D7A-4757-AEE6-F1479127B0B4}"/>
               </a:ext>
             </a:extLst>
           </p:cNvPr>
@@ -4114,7 +4114,7 @@
           <p:cNvPr id="8" name="">
             <a:extLst xmlns:a="http://schemas.openxmlformats.org/drawingml/2006/main">
               <a:ext uri="{FF2B5EF4-FFF2-40B4-BE49-F238E27FC236}">
-                <a16:creationId xmlns:a16="http://schemas.microsoft.com/office/drawing/2014/main" id="{47624FD3-6F34-433D-8EF1-3FE68586BABE}"/>
+                <a16:creationId xmlns:a16="http://schemas.microsoft.com/office/drawing/2014/main" id="{938EC07A-0C75-46E7-955D-7A3602A20D0F}"/>
               </a:ext>
             </a:extLst>
           </p:cNvPr>
@@ -4164,7 +4164,7 @@
           <p:cNvPr id="9" name="">
             <a:extLst xmlns:a="http://schemas.openxmlformats.org/drawingml/2006/main">
               <a:ext uri="{FF2B5EF4-FFF2-40B4-BE49-F238E27FC236}">
-                <a16:creationId xmlns:a16="http://schemas.microsoft.com/office/drawing/2014/main" id="{0F5235ED-350C-40BE-8ACE-A5C672DC7D1D}"/>
+                <a16:creationId xmlns:a16="http://schemas.microsoft.com/office/drawing/2014/main" id="{F7AA40F7-1709-4903-A965-E84FDDBC1D1E}"/>
               </a:ext>
             </a:extLst>
           </p:cNvPr>
@@ -4214,7 +4214,7 @@
           <p:cNvPr id="10" name="">
             <a:extLst xmlns:a="http://schemas.openxmlformats.org/drawingml/2006/main">
               <a:ext uri="{FF2B5EF4-FFF2-40B4-BE49-F238E27FC236}">
-                <a16:creationId xmlns:a16="http://schemas.microsoft.com/office/drawing/2014/main" id="{E6F1BF4E-654E-473D-A1D2-32CED579388C}"/>
+                <a16:creationId xmlns:a16="http://schemas.microsoft.com/office/drawing/2014/main" id="{E68E93E3-B302-41A4-8398-1F2FD92FB199}"/>
               </a:ext>
             </a:extLst>
           </p:cNvPr>
@@ -4245,7 +4245,7 @@
           <p:cNvPr id="11" name="">
             <a:extLst xmlns:a="http://schemas.openxmlformats.org/drawingml/2006/main">
               <a:ext uri="{FF2B5EF4-FFF2-40B4-BE49-F238E27FC236}">
-                <a16:creationId xmlns:a16="http://schemas.microsoft.com/office/drawing/2014/main" id="{E43D0B2E-B1C5-4658-BBD9-E99154A4FF7E}"/>
+                <a16:creationId xmlns:a16="http://schemas.microsoft.com/office/drawing/2014/main" id="{5302CBB6-11FA-4A50-9C9F-84D354B6370A}"/>
               </a:ext>
             </a:extLst>
           </p:cNvPr>
@@ -4295,7 +4295,7 @@
           <p:cNvPr id="12" name="">
             <a:extLst xmlns:a="http://schemas.openxmlformats.org/drawingml/2006/main">
               <a:ext uri="{FF2B5EF4-FFF2-40B4-BE49-F238E27FC236}">
-                <a16:creationId xmlns:a16="http://schemas.microsoft.com/office/drawing/2014/main" id="{E99371D0-CE30-4909-A267-6C43EB3C0A74}"/>
+                <a16:creationId xmlns:a16="http://schemas.microsoft.com/office/drawing/2014/main" id="{60746C61-ED8A-4403-9B53-F4FCD4925E46}"/>
               </a:ext>
             </a:extLst>
           </p:cNvPr>
@@ -4345,7 +4345,7 @@
           <p:cNvPr id="13" name="">
             <a:extLst xmlns:a="http://schemas.openxmlformats.org/drawingml/2006/main">
               <a:ext uri="{FF2B5EF4-FFF2-40B4-BE49-F238E27FC236}">
-                <a16:creationId xmlns:a16="http://schemas.microsoft.com/office/drawing/2014/main" id="{E211C801-7BE4-445C-9A7F-C03B1466E285}"/>
+                <a16:creationId xmlns:a16="http://schemas.microsoft.com/office/drawing/2014/main" id="{698097E1-CD91-4292-912E-2503DA6819D2}"/>
               </a:ext>
             </a:extLst>
           </p:cNvPr>
@@ -4376,7 +4376,7 @@
           <p:cNvPr id="14" name="">
             <a:extLst xmlns:a="http://schemas.openxmlformats.org/drawingml/2006/main">
               <a:ext uri="{FF2B5EF4-FFF2-40B4-BE49-F238E27FC236}">
-                <a16:creationId xmlns:a16="http://schemas.microsoft.com/office/drawing/2014/main" id="{88662DF6-1C5A-4B46-8894-8C4DF498DDA9}"/>
+                <a16:creationId xmlns:a16="http://schemas.microsoft.com/office/drawing/2014/main" id="{DB495A3B-F258-4B66-8B9E-DD85B4FAFDA1}"/>
               </a:ext>
             </a:extLst>
           </p:cNvPr>
@@ -4426,7 +4426,7 @@
           <p:cNvPr id="15" name="">
             <a:extLst xmlns:a="http://schemas.openxmlformats.org/drawingml/2006/main">
               <a:ext uri="{FF2B5EF4-FFF2-40B4-BE49-F238E27FC236}">
-                <a16:creationId xmlns:a16="http://schemas.microsoft.com/office/drawing/2014/main" id="{8DD06E4B-DE78-4B42-BA13-19C32BFA1A28}"/>
+                <a16:creationId xmlns:a16="http://schemas.microsoft.com/office/drawing/2014/main" id="{56EB46A0-29CE-49AD-B755-4F54CC101180}"/>
               </a:ext>
             </a:extLst>
           </p:cNvPr>
@@ -4476,7 +4476,7 @@
           <p:cNvPr id="16" name="">
             <a:extLst xmlns:a="http://schemas.openxmlformats.org/drawingml/2006/main">
               <a:ext uri="{FF2B5EF4-FFF2-40B4-BE49-F238E27FC236}">
-                <a16:creationId xmlns:a16="http://schemas.microsoft.com/office/drawing/2014/main" id="{FA32F283-0352-42A8-A71D-A2C0C1299E1F}"/>
+                <a16:creationId xmlns:a16="http://schemas.microsoft.com/office/drawing/2014/main" id="{5818DD89-3D5F-4E63-A49E-F44FD5D6557B}"/>
               </a:ext>
             </a:extLst>
           </p:cNvPr>
@@ -4507,7 +4507,7 @@
           <p:cNvPr id="17" name="">
             <a:extLst xmlns:a="http://schemas.openxmlformats.org/drawingml/2006/main">
               <a:ext uri="{FF2B5EF4-FFF2-40B4-BE49-F238E27FC236}">
-                <a16:creationId xmlns:a16="http://schemas.microsoft.com/office/drawing/2014/main" id="{7E761F8E-66FA-4F0C-856E-9CB460292A9D}"/>
+                <a16:creationId xmlns:a16="http://schemas.microsoft.com/office/drawing/2014/main" id="{585D6EB4-13D7-422F-AC83-E0D6647B1BCD}"/>
               </a:ext>
             </a:extLst>
           </p:cNvPr>
@@ -4557,7 +4557,7 @@
           <p:cNvPr id="18" name="">
             <a:extLst xmlns:a="http://schemas.openxmlformats.org/drawingml/2006/main">
               <a:ext uri="{FF2B5EF4-FFF2-40B4-BE49-F238E27FC236}">
-                <a16:creationId xmlns:a16="http://schemas.microsoft.com/office/drawing/2014/main" id="{0D65F523-F98E-4D35-8908-851781B3E65B}"/>
+                <a16:creationId xmlns:a16="http://schemas.microsoft.com/office/drawing/2014/main" id="{8C809470-2F53-4529-8EEF-BC32DD073842}"/>
               </a:ext>
             </a:extLst>
           </p:cNvPr>
@@ -4607,7 +4607,7 @@
           <p:cNvPr id="19" name="">
             <a:extLst xmlns:a="http://schemas.openxmlformats.org/drawingml/2006/main">
               <a:ext uri="{FF2B5EF4-FFF2-40B4-BE49-F238E27FC236}">
-                <a16:creationId xmlns:a16="http://schemas.microsoft.com/office/drawing/2014/main" id="{A5201676-B3EB-479B-8B90-1F644678E874}"/>
+                <a16:creationId xmlns:a16="http://schemas.microsoft.com/office/drawing/2014/main" id="{6EAC8663-F684-4A94-A5FD-52D108FA26EB}"/>
               </a:ext>
             </a:extLst>
           </p:cNvPr>
@@ -4640,7 +4640,7 @@
           <p:cNvPr id="20" name="">
             <a:extLst xmlns:a="http://schemas.openxmlformats.org/drawingml/2006/main">
               <a:ext uri="{FF2B5EF4-FFF2-40B4-BE49-F238E27FC236}">
-                <a16:creationId xmlns:a16="http://schemas.microsoft.com/office/drawing/2014/main" id="{F6B4399C-B427-4BB9-86EF-577E4770DDE3}"/>
+                <a16:creationId xmlns:a16="http://schemas.microsoft.com/office/drawing/2014/main" id="{3CC70289-6DD2-4A9E-92BD-5BBDDFB3B95E}"/>
               </a:ext>
             </a:extLst>
           </p:cNvPr>
@@ -4690,7 +4690,7 @@
           <p:cNvPr id="21" name="">
             <a:extLst xmlns:a="http://schemas.openxmlformats.org/drawingml/2006/main">
               <a:ext uri="{FF2B5EF4-FFF2-40B4-BE49-F238E27FC236}">
-                <a16:creationId xmlns:a16="http://schemas.microsoft.com/office/drawing/2014/main" id="{D2095020-3563-486F-B93A-D1DB85D3ED7E}"/>
+                <a16:creationId xmlns:a16="http://schemas.microsoft.com/office/drawing/2014/main" id="{DA274DFB-AF9E-46DB-B687-30708EC5F712}"/>
               </a:ext>
             </a:extLst>
           </p:cNvPr>
@@ -4740,7 +4740,7 @@
           <p:cNvPr id="22" name="">
             <a:extLst xmlns:a="http://schemas.openxmlformats.org/drawingml/2006/main">
               <a:ext uri="{FF2B5EF4-FFF2-40B4-BE49-F238E27FC236}">
-                <a16:creationId xmlns:a16="http://schemas.microsoft.com/office/drawing/2014/main" id="{8401FD1C-745E-4B6E-B5E2-A6456F68F902}"/>
+                <a16:creationId xmlns:a16="http://schemas.microsoft.com/office/drawing/2014/main" id="{7177D3A5-C778-4A7B-BE3F-2FF1B9F5A74F}"/>
               </a:ext>
             </a:extLst>
           </p:cNvPr>
@@ -4824,7 +4824,7 @@
           <p:cNvPr id="23" name="">
             <a:extLst xmlns:a="http://schemas.openxmlformats.org/drawingml/2006/main">
               <a:ext uri="{FF2B5EF4-FFF2-40B4-BE49-F238E27FC236}">
-                <a16:creationId xmlns:a16="http://schemas.microsoft.com/office/drawing/2014/main" id="{B4934307-A94D-452E-86ED-D5EC1E5B09D2}"/>
+                <a16:creationId xmlns:a16="http://schemas.microsoft.com/office/drawing/2014/main" id="{52FE83CE-5D68-42D4-B867-ADFD8CA286BC}"/>
               </a:ext>
             </a:extLst>
           </p:cNvPr>
@@ -4874,7 +4874,7 @@
           <p:cNvPr id="24" name="">
             <a:extLst xmlns:a="http://schemas.openxmlformats.org/drawingml/2006/main">
               <a:ext uri="{FF2B5EF4-FFF2-40B4-BE49-F238E27FC236}">
-                <a16:creationId xmlns:a16="http://schemas.microsoft.com/office/drawing/2014/main" id="{06D7716F-5BE1-4C41-9F8A-2D401BB06B62}"/>
+                <a16:creationId xmlns:a16="http://schemas.microsoft.com/office/drawing/2014/main" id="{E8C83522-2919-4391-8D5D-25B1FF76C57E}"/>
               </a:ext>
             </a:extLst>
           </p:cNvPr>
@@ -4922,7 +4922,7 @@
     </p:spTree>
     <p:extLst>
       <p:ext uri="{BB962C8B-B14F-4D97-AF65-F5344CB8AC3E}">
-        <p14:creationId xmlns:p14="http://schemas.microsoft.com/office/powerpoint/2010/main" val="1799591257"/>
+        <p14:creationId xmlns:p14="http://schemas.microsoft.com/office/powerpoint/2010/main" val="1224087253"/>
       </p:ext>
     </p:extLst>
   </p:cSld>
@@ -4946,7 +4946,7 @@
           <p:cNvPr id="1" name="">
             <a:extLst xmlns:a="http://schemas.openxmlformats.org/drawingml/2006/main">
               <a:ext uri="{FF2B5EF4-FFF2-40B4-BE49-F238E27FC236}">
-                <a16:creationId xmlns:a16="http://schemas.microsoft.com/office/drawing/2014/main" id="{C291D42D-27FC-4921-A2F1-BEFEF917650C}"/>
+                <a16:creationId xmlns:a16="http://schemas.microsoft.com/office/drawing/2014/main" id="{642AC264-7893-4AD7-9088-05FB8394CA0C}"/>
               </a:ext>
             </a:extLst>
           </p:cNvPr>
@@ -4996,7 +4996,7 @@
           <p:cNvPr id="2" name="">
             <a:extLst xmlns:a="http://schemas.openxmlformats.org/drawingml/2006/main">
               <a:ext uri="{FF2B5EF4-FFF2-40B4-BE49-F238E27FC236}">
-                <a16:creationId xmlns:a16="http://schemas.microsoft.com/office/drawing/2014/main" id="{C74C2A08-BF00-4C7C-8E0C-8A0B80EE6C5A}"/>
+                <a16:creationId xmlns:a16="http://schemas.microsoft.com/office/drawing/2014/main" id="{E1686747-C3D5-4F25-A698-8A6AEB811A06}"/>
               </a:ext>
             </a:extLst>
           </p:cNvPr>
@@ -5046,7 +5046,7 @@
           <p:cNvPr id="3" name="">
             <a:extLst xmlns:a="http://schemas.openxmlformats.org/drawingml/2006/main">
               <a:ext uri="{FF2B5EF4-FFF2-40B4-BE49-F238E27FC236}">
-                <a16:creationId xmlns:a16="http://schemas.microsoft.com/office/drawing/2014/main" id="{9EA67F66-798E-42DA-93B6-DC87BE347513}"/>
+                <a16:creationId xmlns:a16="http://schemas.microsoft.com/office/drawing/2014/main" id="{6484CC19-9BFC-4228-B61E-1414F404049B}"/>
               </a:ext>
             </a:extLst>
           </p:cNvPr>
@@ -5330,7 +5330,7 @@
           <p:cNvPr id="5" name="">
             <a:extLst xmlns:a="http://schemas.openxmlformats.org/drawingml/2006/main">
               <a:ext uri="{FF2B5EF4-FFF2-40B4-BE49-F238E27FC236}">
-                <a16:creationId xmlns:a16="http://schemas.microsoft.com/office/drawing/2014/main" id="{2EB886C0-3E6A-4897-B697-6EE26C1C9EBD}"/>
+                <a16:creationId xmlns:a16="http://schemas.microsoft.com/office/drawing/2014/main" id="{DB38CB20-67A6-4802-861D-DC52EE7E7F55}"/>
               </a:ext>
             </a:extLst>
           </p:cNvPr>
@@ -5380,7 +5380,7 @@
           <p:cNvPr id="6" name="">
             <a:extLst xmlns:a="http://schemas.openxmlformats.org/drawingml/2006/main">
               <a:ext uri="{FF2B5EF4-FFF2-40B4-BE49-F238E27FC236}">
-                <a16:creationId xmlns:a16="http://schemas.microsoft.com/office/drawing/2014/main" id="{16D089A2-7020-4AD9-B1A5-EDABADFAF418}"/>
+                <a16:creationId xmlns:a16="http://schemas.microsoft.com/office/drawing/2014/main" id="{11279089-4539-4181-B8E2-F6CE1C9654BB}"/>
               </a:ext>
             </a:extLst>
           </p:cNvPr>
@@ -5428,7 +5428,7 @@
     </p:spTree>
     <p:extLst>
       <p:ext uri="{BB962C8B-B14F-4D97-AF65-F5344CB8AC3E}">
-        <p14:creationId xmlns:p14="http://schemas.microsoft.com/office/powerpoint/2010/main" val="2032049181"/>
+        <p14:creationId xmlns:p14="http://schemas.microsoft.com/office/powerpoint/2010/main" val="1378124693"/>
       </p:ext>
     </p:extLst>
   </p:cSld>
@@ -5452,7 +5452,7 @@
           <p:cNvPr id="1" name="">
             <a:extLst xmlns:a="http://schemas.openxmlformats.org/drawingml/2006/main">
               <a:ext uri="{FF2B5EF4-FFF2-40B4-BE49-F238E27FC236}">
-                <a16:creationId xmlns:a16="http://schemas.microsoft.com/office/drawing/2014/main" id="{99DA7EA9-9BFC-4D53-A36E-B940A3CEF8FA}"/>
+                <a16:creationId xmlns:a16="http://schemas.microsoft.com/office/drawing/2014/main" id="{8312A3FB-B62C-406A-B993-AE707C2EC9C4}"/>
               </a:ext>
             </a:extLst>
           </p:cNvPr>
@@ -5502,7 +5502,7 @@
           <p:cNvPr id="2" name="">
             <a:extLst xmlns:a="http://schemas.openxmlformats.org/drawingml/2006/main">
               <a:ext uri="{FF2B5EF4-FFF2-40B4-BE49-F238E27FC236}">
-                <a16:creationId xmlns:a16="http://schemas.microsoft.com/office/drawing/2014/main" id="{D4340710-01F5-48FD-ABD5-0947A32818E4}"/>
+                <a16:creationId xmlns:a16="http://schemas.microsoft.com/office/drawing/2014/main" id="{E5FDA60E-42D5-4A18-A554-22F6E1ED006E}"/>
               </a:ext>
             </a:extLst>
           </p:cNvPr>
@@ -5552,7 +5552,7 @@
           <p:cNvPr id="3" name="">
             <a:extLst xmlns:a="http://schemas.openxmlformats.org/drawingml/2006/main">
               <a:ext uri="{FF2B5EF4-FFF2-40B4-BE49-F238E27FC236}">
-                <a16:creationId xmlns:a16="http://schemas.microsoft.com/office/drawing/2014/main" id="{CC3A1FEA-8086-4BC5-94AE-888D1385EB3F}"/>
+                <a16:creationId xmlns:a16="http://schemas.microsoft.com/office/drawing/2014/main" id="{46C55E2B-1CD9-4D4E-AD8A-2959A41740CB}"/>
               </a:ext>
             </a:extLst>
           </p:cNvPr>
@@ -5585,7 +5585,7 @@
           <p:cNvPr id="4" name="">
             <a:extLst xmlns:a="http://schemas.openxmlformats.org/drawingml/2006/main">
               <a:ext uri="{FF2B5EF4-FFF2-40B4-BE49-F238E27FC236}">
-                <a16:creationId xmlns:a16="http://schemas.microsoft.com/office/drawing/2014/main" id="{6F7B1AB9-EE68-4F56-BA4B-9A2449ABA8AB}"/>
+                <a16:creationId xmlns:a16="http://schemas.microsoft.com/office/drawing/2014/main" id="{6D22ACC0-88EF-4010-B4A3-0AAC9A42CFD9}"/>
               </a:ext>
             </a:extLst>
           </p:cNvPr>
@@ -5616,7 +5616,7 @@
           <p:cNvPr id="5" name="">
             <a:extLst xmlns:a="http://schemas.openxmlformats.org/drawingml/2006/main">
               <a:ext uri="{FF2B5EF4-FFF2-40B4-BE49-F238E27FC236}">
-                <a16:creationId xmlns:a16="http://schemas.microsoft.com/office/drawing/2014/main" id="{E3E4E8F1-A508-48D6-BF51-1635F4D3149C}"/>
+                <a16:creationId xmlns:a16="http://schemas.microsoft.com/office/drawing/2014/main" id="{360E52E9-1F7E-4A56-AF9C-F8EBA23E0340}"/>
               </a:ext>
             </a:extLst>
           </p:cNvPr>
@@ -5666,7 +5666,7 @@
           <p:cNvPr id="6" name="">
             <a:extLst xmlns:a="http://schemas.openxmlformats.org/drawingml/2006/main">
               <a:ext uri="{FF2B5EF4-FFF2-40B4-BE49-F238E27FC236}">
-                <a16:creationId xmlns:a16="http://schemas.microsoft.com/office/drawing/2014/main" id="{0BC7E8A5-06E8-4D1C-9AE3-0C6061CA478D}"/>
+                <a16:creationId xmlns:a16="http://schemas.microsoft.com/office/drawing/2014/main" id="{985B8E5C-2B8B-454D-B668-21B7687AD8AE}"/>
               </a:ext>
             </a:extLst>
           </p:cNvPr>
@@ -5767,7 +5767,7 @@
           <p:cNvPr id="7" name="">
             <a:extLst xmlns:a="http://schemas.openxmlformats.org/drawingml/2006/main">
               <a:ext uri="{FF2B5EF4-FFF2-40B4-BE49-F238E27FC236}">
-                <a16:creationId xmlns:a16="http://schemas.microsoft.com/office/drawing/2014/main" id="{78D88072-D285-4C2E-AA67-D65217C32E1C}"/>
+                <a16:creationId xmlns:a16="http://schemas.microsoft.com/office/drawing/2014/main" id="{9912AA88-C04A-4D57-86D1-50EF6AC70028}"/>
               </a:ext>
             </a:extLst>
           </p:cNvPr>
@@ -5798,7 +5798,7 @@
           <p:cNvPr id="8" name="">
             <a:extLst xmlns:a="http://schemas.openxmlformats.org/drawingml/2006/main">
               <a:ext uri="{FF2B5EF4-FFF2-40B4-BE49-F238E27FC236}">
-                <a16:creationId xmlns:a16="http://schemas.microsoft.com/office/drawing/2014/main" id="{43809371-45C4-423D-A097-3907CAA9E077}"/>
+                <a16:creationId xmlns:a16="http://schemas.microsoft.com/office/drawing/2014/main" id="{8670EB3A-1247-4F8C-B5F2-1F9C9CAF327C}"/>
               </a:ext>
             </a:extLst>
           </p:cNvPr>
@@ -5848,7 +5848,7 @@
           <p:cNvPr id="9" name="">
             <a:extLst xmlns:a="http://schemas.openxmlformats.org/drawingml/2006/main">
               <a:ext uri="{FF2B5EF4-FFF2-40B4-BE49-F238E27FC236}">
-                <a16:creationId xmlns:a16="http://schemas.microsoft.com/office/drawing/2014/main" id="{A71C47BB-80CC-4EFF-A3DE-83A8A09ADD52}"/>
+                <a16:creationId xmlns:a16="http://schemas.microsoft.com/office/drawing/2014/main" id="{62FA1F9D-9F06-4A73-A6DB-778039274CEF}"/>
               </a:ext>
             </a:extLst>
           </p:cNvPr>
@@ -5949,7 +5949,7 @@
           <p:cNvPr id="10" name="">
             <a:extLst xmlns:a="http://schemas.openxmlformats.org/drawingml/2006/main">
               <a:ext uri="{FF2B5EF4-FFF2-40B4-BE49-F238E27FC236}">
-                <a16:creationId xmlns:a16="http://schemas.microsoft.com/office/drawing/2014/main" id="{2387D5F4-E68E-4BD1-9F6D-7E8947F9E722}"/>
+                <a16:creationId xmlns:a16="http://schemas.microsoft.com/office/drawing/2014/main" id="{5AB549F7-26B0-4149-B91F-22E7B00D97F8}"/>
               </a:ext>
             </a:extLst>
           </p:cNvPr>
@@ -5999,7 +5999,7 @@
           <p:cNvPr id="11" name="">
             <a:extLst xmlns:a="http://schemas.openxmlformats.org/drawingml/2006/main">
               <a:ext uri="{FF2B5EF4-FFF2-40B4-BE49-F238E27FC236}">
-                <a16:creationId xmlns:a16="http://schemas.microsoft.com/office/drawing/2014/main" id="{9FF89CC8-EE9B-451A-BB5A-5C66CD31D935}"/>
+                <a16:creationId xmlns:a16="http://schemas.microsoft.com/office/drawing/2014/main" id="{1D8323AF-6DA4-4841-B4C7-8431F6E01761}"/>
               </a:ext>
             </a:extLst>
           </p:cNvPr>
@@ -6047,7 +6047,7 @@
     </p:spTree>
     <p:extLst>
       <p:ext uri="{BB962C8B-B14F-4D97-AF65-F5344CB8AC3E}">
-        <p14:creationId xmlns:p14="http://schemas.microsoft.com/office/powerpoint/2010/main" val="797515899"/>
+        <p14:creationId xmlns:p14="http://schemas.microsoft.com/office/powerpoint/2010/main" val="2093930443"/>
       </p:ext>
     </p:extLst>
   </p:cSld>
@@ -6071,7 +6071,7 @@
           <p:cNvPr id="1" name="">
             <a:extLst xmlns:a="http://schemas.openxmlformats.org/drawingml/2006/main">
               <a:ext uri="{FF2B5EF4-FFF2-40B4-BE49-F238E27FC236}">
-                <a16:creationId xmlns:a16="http://schemas.microsoft.com/office/drawing/2014/main" id="{086C7CFB-A070-455D-94C4-726915E2862E}"/>
+                <a16:creationId xmlns:a16="http://schemas.microsoft.com/office/drawing/2014/main" id="{6726667C-E727-41FB-A09A-E2FE963B7C75}"/>
               </a:ext>
             </a:extLst>
           </p:cNvPr>
@@ -6121,7 +6121,7 @@
           <p:cNvPr id="2" name="">
             <a:extLst xmlns:a="http://schemas.openxmlformats.org/drawingml/2006/main">
               <a:ext uri="{FF2B5EF4-FFF2-40B4-BE49-F238E27FC236}">
-                <a16:creationId xmlns:a16="http://schemas.microsoft.com/office/drawing/2014/main" id="{F871A189-F72D-4A29-9FD5-F3B3CAF0CC26}"/>
+                <a16:creationId xmlns:a16="http://schemas.microsoft.com/office/drawing/2014/main" id="{BB8E8657-5A4C-4C83-8D59-430B74C2C206}"/>
               </a:ext>
             </a:extLst>
           </p:cNvPr>
@@ -6171,7 +6171,7 @@
           <p:cNvPr id="3" name="">
             <a:extLst xmlns:a="http://schemas.openxmlformats.org/drawingml/2006/main">
               <a:ext uri="{FF2B5EF4-FFF2-40B4-BE49-F238E27FC236}">
-                <a16:creationId xmlns:a16="http://schemas.microsoft.com/office/drawing/2014/main" id="{C905BE7E-53FB-4170-866F-B866BDE4D10F}"/>
+                <a16:creationId xmlns:a16="http://schemas.microsoft.com/office/drawing/2014/main" id="{96A343A1-C67C-4383-974F-0FF90C5B0786}"/>
               </a:ext>
             </a:extLst>
           </p:cNvPr>
@@ -6211,7 +6211,7 @@
         </p:xfrm>
         <a:graphic xmlns:a="http://schemas.openxmlformats.org/drawingml/2006/main">
           <a:graphicData uri="http://schemas.openxmlformats.org/drawingml/2006/chart">
-            <c:chart xmlns:r="http://schemas.openxmlformats.org/officeDocument/2006/relationships" xmlns:c="http://schemas.openxmlformats.org/drawingml/2006/chart" r:id="R051059f82ffd46cc"/>
+            <c:chart xmlns:r="http://schemas.openxmlformats.org/officeDocument/2006/relationships" xmlns:c="http://schemas.openxmlformats.org/drawingml/2006/chart" r:id="R2bb16f81f8494a2f"/>
           </a:graphicData>
         </a:graphic>
       </p:graphicFrame>
@@ -6220,7 +6220,7 @@
           <p:cNvPr id="5" name="">
             <a:extLst xmlns:a="http://schemas.openxmlformats.org/drawingml/2006/main">
               <a:ext uri="{FF2B5EF4-FFF2-40B4-BE49-F238E27FC236}">
-                <a16:creationId xmlns:a16="http://schemas.microsoft.com/office/drawing/2014/main" id="{90098E08-4F20-4FC7-8311-02A78394A163}"/>
+                <a16:creationId xmlns:a16="http://schemas.microsoft.com/office/drawing/2014/main" id="{0A29B9CA-A781-4EC2-A712-4C8DAF5C11D1}"/>
               </a:ext>
             </a:extLst>
           </p:cNvPr>
@@ -6270,7 +6270,7 @@
           <p:cNvPr id="6" name="">
             <a:extLst xmlns:a="http://schemas.openxmlformats.org/drawingml/2006/main">
               <a:ext uri="{FF2B5EF4-FFF2-40B4-BE49-F238E27FC236}">
-                <a16:creationId xmlns:a16="http://schemas.microsoft.com/office/drawing/2014/main" id="{F3D72596-ACBF-4CA1-B640-6BBDB5AE5C5F}"/>
+                <a16:creationId xmlns:a16="http://schemas.microsoft.com/office/drawing/2014/main" id="{48B8DB55-EFD5-4147-ACB4-EDFA9105FFE0}"/>
               </a:ext>
             </a:extLst>
           </p:cNvPr>
@@ -6371,7 +6371,7 @@
           <p:cNvPr id="7" name="">
             <a:extLst xmlns:a="http://schemas.openxmlformats.org/drawingml/2006/main">
               <a:ext uri="{FF2B5EF4-FFF2-40B4-BE49-F238E27FC236}">
-                <a16:creationId xmlns:a16="http://schemas.microsoft.com/office/drawing/2014/main" id="{11AE309F-90D5-45FF-B1BB-6DCC6CE7D60D}"/>
+                <a16:creationId xmlns:a16="http://schemas.microsoft.com/office/drawing/2014/main" id="{891FF3BD-D52B-4A7D-8D96-4C0263AD22DD}"/>
               </a:ext>
             </a:extLst>
           </p:cNvPr>
@@ -6421,7 +6421,7 @@
           <p:cNvPr id="8" name="">
             <a:extLst xmlns:a="http://schemas.openxmlformats.org/drawingml/2006/main">
               <a:ext uri="{FF2B5EF4-FFF2-40B4-BE49-F238E27FC236}">
-                <a16:creationId xmlns:a16="http://schemas.microsoft.com/office/drawing/2014/main" id="{A48F1565-A2E1-4A3B-9E5D-60475CEF89BE}"/>
+                <a16:creationId xmlns:a16="http://schemas.microsoft.com/office/drawing/2014/main" id="{0BD5B43E-CC06-4B9B-8008-54B25EE647B7}"/>
               </a:ext>
             </a:extLst>
           </p:cNvPr>
@@ -6471,7 +6471,7 @@
           <p:cNvPr id="9" name="">
             <a:extLst xmlns:a="http://schemas.openxmlformats.org/drawingml/2006/main">
               <a:ext uri="{FF2B5EF4-FFF2-40B4-BE49-F238E27FC236}">
-                <a16:creationId xmlns:a16="http://schemas.microsoft.com/office/drawing/2014/main" id="{3BAB8D94-29C1-4282-AB08-9F2AB09DF95A}"/>
+                <a16:creationId xmlns:a16="http://schemas.microsoft.com/office/drawing/2014/main" id="{AD90E024-C887-434F-8A64-68D088249E71}"/>
               </a:ext>
             </a:extLst>
           </p:cNvPr>
@@ -6519,7 +6519,7 @@
     </p:spTree>
     <p:extLst>
       <p:ext uri="{BB962C8B-B14F-4D97-AF65-F5344CB8AC3E}">
-        <p14:creationId xmlns:p14="http://schemas.microsoft.com/office/powerpoint/2010/main" val="1861094768"/>
+        <p14:creationId xmlns:p14="http://schemas.microsoft.com/office/powerpoint/2010/main" val="957882927"/>
       </p:ext>
     </p:extLst>
   </p:cSld>
@@ -6543,7 +6543,7 @@
           <p:cNvPr id="1" name="">
             <a:extLst xmlns:a="http://schemas.openxmlformats.org/drawingml/2006/main">
               <a:ext uri="{FF2B5EF4-FFF2-40B4-BE49-F238E27FC236}">
-                <a16:creationId xmlns:a16="http://schemas.microsoft.com/office/drawing/2014/main" id="{107C1652-F08A-4992-B1ED-062B04D7DAFF}"/>
+                <a16:creationId xmlns:a16="http://schemas.microsoft.com/office/drawing/2014/main" id="{4224BFEB-2853-479D-8ECC-78E886C31870}"/>
               </a:ext>
             </a:extLst>
           </p:cNvPr>
@@ -6593,7 +6593,7 @@
           <p:cNvPr id="2" name="">
             <a:extLst xmlns:a="http://schemas.openxmlformats.org/drawingml/2006/main">
               <a:ext uri="{FF2B5EF4-FFF2-40B4-BE49-F238E27FC236}">
-                <a16:creationId xmlns:a16="http://schemas.microsoft.com/office/drawing/2014/main" id="{A7F9C593-7B1F-4D8A-96A5-7295B5274327}"/>
+                <a16:creationId xmlns:a16="http://schemas.microsoft.com/office/drawing/2014/main" id="{10530457-8EEB-4C6B-9B40-AD18482826E3}"/>
               </a:ext>
             </a:extLst>
           </p:cNvPr>
@@ -6643,7 +6643,7 @@
           <p:cNvPr id="3" name="">
             <a:extLst xmlns:a="http://schemas.openxmlformats.org/drawingml/2006/main">
               <a:ext uri="{FF2B5EF4-FFF2-40B4-BE49-F238E27FC236}">
-                <a16:creationId xmlns:a16="http://schemas.microsoft.com/office/drawing/2014/main" id="{1875947E-E26A-45B6-ACE6-1116810DFCA2}"/>
+                <a16:creationId xmlns:a16="http://schemas.microsoft.com/office/drawing/2014/main" id="{EC6FB797-8166-419B-AE0C-425C9DE79B9A}"/>
               </a:ext>
             </a:extLst>
           </p:cNvPr>
@@ -6676,7 +6676,7 @@
           <p:cNvPr id="4" name="">
             <a:extLst xmlns:a="http://schemas.openxmlformats.org/drawingml/2006/main">
               <a:ext uri="{FF2B5EF4-FFF2-40B4-BE49-F238E27FC236}">
-                <a16:creationId xmlns:a16="http://schemas.microsoft.com/office/drawing/2014/main" id="{096B1963-7472-4746-A5DD-F9994BD4E368}"/>
+                <a16:creationId xmlns:a16="http://schemas.microsoft.com/office/drawing/2014/main" id="{CCE2754A-631F-4CE3-B6C6-44FA66FB15F0}"/>
               </a:ext>
             </a:extLst>
           </p:cNvPr>
@@ -6707,7 +6707,7 @@
           <p:cNvPr id="5" name="">
             <a:extLst xmlns:a="http://schemas.openxmlformats.org/drawingml/2006/main">
               <a:ext uri="{FF2B5EF4-FFF2-40B4-BE49-F238E27FC236}">
-                <a16:creationId xmlns:a16="http://schemas.microsoft.com/office/drawing/2014/main" id="{6C750FA0-00C0-44EE-84E4-08C4C52F3E32}"/>
+                <a16:creationId xmlns:a16="http://schemas.microsoft.com/office/drawing/2014/main" id="{9F07A042-6F69-4AC7-9E15-0FE3FFEB9AE6}"/>
               </a:ext>
             </a:extLst>
           </p:cNvPr>
@@ -6757,7 +6757,7 @@
           <p:cNvPr id="6" name="">
             <a:extLst xmlns:a="http://schemas.openxmlformats.org/drawingml/2006/main">
               <a:ext uri="{FF2B5EF4-FFF2-40B4-BE49-F238E27FC236}">
-                <a16:creationId xmlns:a16="http://schemas.microsoft.com/office/drawing/2014/main" id="{7C07583C-E82B-4C90-845B-D57A43814900}"/>
+                <a16:creationId xmlns:a16="http://schemas.microsoft.com/office/drawing/2014/main" id="{21CDCB43-F15D-40B4-904C-5244086519FE}"/>
               </a:ext>
             </a:extLst>
           </p:cNvPr>
@@ -6807,7 +6807,7 @@
           <p:cNvPr id="7" name="">
             <a:extLst xmlns:a="http://schemas.openxmlformats.org/drawingml/2006/main">
               <a:ext uri="{FF2B5EF4-FFF2-40B4-BE49-F238E27FC236}">
-                <a16:creationId xmlns:a16="http://schemas.microsoft.com/office/drawing/2014/main" id="{0990857E-8466-438A-A1AD-0AEEA8BEC98F}"/>
+                <a16:creationId xmlns:a16="http://schemas.microsoft.com/office/drawing/2014/main" id="{6C7C5C7E-EC4A-4E2D-A3BF-F0CFF3B21AE1}"/>
               </a:ext>
             </a:extLst>
           </p:cNvPr>
@@ -6838,7 +6838,7 @@
           <p:cNvPr id="8" name="">
             <a:extLst xmlns:a="http://schemas.openxmlformats.org/drawingml/2006/main">
               <a:ext uri="{FF2B5EF4-FFF2-40B4-BE49-F238E27FC236}">
-                <a16:creationId xmlns:a16="http://schemas.microsoft.com/office/drawing/2014/main" id="{1F889CF4-01CA-444C-8872-B6E248CD6896}"/>
+                <a16:creationId xmlns:a16="http://schemas.microsoft.com/office/drawing/2014/main" id="{51F6501E-BF5C-4C83-AAB0-F8DD92126945}"/>
               </a:ext>
             </a:extLst>
           </p:cNvPr>
@@ -6888,7 +6888,7 @@
           <p:cNvPr id="9" name="">
             <a:extLst xmlns:a="http://schemas.openxmlformats.org/drawingml/2006/main">
               <a:ext uri="{FF2B5EF4-FFF2-40B4-BE49-F238E27FC236}">
-                <a16:creationId xmlns:a16="http://schemas.microsoft.com/office/drawing/2014/main" id="{7E801B5F-4D91-4696-9514-3A557CC5B251}"/>
+                <a16:creationId xmlns:a16="http://schemas.microsoft.com/office/drawing/2014/main" id="{BE91CCD0-0344-4721-B96D-B41D825F2400}"/>
               </a:ext>
             </a:extLst>
           </p:cNvPr>
@@ -6938,7 +6938,7 @@
           <p:cNvPr id="10" name="">
             <a:extLst xmlns:a="http://schemas.openxmlformats.org/drawingml/2006/main">
               <a:ext uri="{FF2B5EF4-FFF2-40B4-BE49-F238E27FC236}">
-                <a16:creationId xmlns:a16="http://schemas.microsoft.com/office/drawing/2014/main" id="{E244D212-3A6B-4531-8F19-7F5A761AD45F}"/>
+                <a16:creationId xmlns:a16="http://schemas.microsoft.com/office/drawing/2014/main" id="{C057C79E-03C4-4398-BDFB-48602E55D054}"/>
               </a:ext>
             </a:extLst>
           </p:cNvPr>
@@ -6969,7 +6969,7 @@
           <p:cNvPr id="11" name="">
             <a:extLst xmlns:a="http://schemas.openxmlformats.org/drawingml/2006/main">
               <a:ext uri="{FF2B5EF4-FFF2-40B4-BE49-F238E27FC236}">
-                <a16:creationId xmlns:a16="http://schemas.microsoft.com/office/drawing/2014/main" id="{76EC9FDC-D09E-493D-970C-B021E34259B6}"/>
+                <a16:creationId xmlns:a16="http://schemas.microsoft.com/office/drawing/2014/main" id="{9A52AB8D-D947-4BC1-A8D9-D73FC8194BED}"/>
               </a:ext>
             </a:extLst>
           </p:cNvPr>
@@ -7019,7 +7019,7 @@
           <p:cNvPr id="12" name="">
             <a:extLst xmlns:a="http://schemas.openxmlformats.org/drawingml/2006/main">
               <a:ext uri="{FF2B5EF4-FFF2-40B4-BE49-F238E27FC236}">
-                <a16:creationId xmlns:a16="http://schemas.microsoft.com/office/drawing/2014/main" id="{C2551770-1150-4FD0-BA88-43CD040B855E}"/>
+                <a16:creationId xmlns:a16="http://schemas.microsoft.com/office/drawing/2014/main" id="{6E4002ED-6C24-4A8E-9CA9-C079364ED4DA}"/>
               </a:ext>
             </a:extLst>
           </p:cNvPr>
@@ -7069,7 +7069,7 @@
           <p:cNvPr id="13" name="">
             <a:extLst xmlns:a="http://schemas.openxmlformats.org/drawingml/2006/main">
               <a:ext uri="{FF2B5EF4-FFF2-40B4-BE49-F238E27FC236}">
-                <a16:creationId xmlns:a16="http://schemas.microsoft.com/office/drawing/2014/main" id="{D5F4488A-BEA3-4486-A8D6-EE4C487E6DBE}"/>
+                <a16:creationId xmlns:a16="http://schemas.microsoft.com/office/drawing/2014/main" id="{E58740BB-C17B-4D2C-B345-44A8C8F02FED}"/>
               </a:ext>
             </a:extLst>
           </p:cNvPr>
@@ -7100,7 +7100,7 @@
           <p:cNvPr id="14" name="">
             <a:extLst xmlns:a="http://schemas.openxmlformats.org/drawingml/2006/main">
               <a:ext uri="{FF2B5EF4-FFF2-40B4-BE49-F238E27FC236}">
-                <a16:creationId xmlns:a16="http://schemas.microsoft.com/office/drawing/2014/main" id="{D03C7959-F0C6-46D1-841A-F25DC9A2BBF4}"/>
+                <a16:creationId xmlns:a16="http://schemas.microsoft.com/office/drawing/2014/main" id="{01B3E7D9-BD8F-445E-A138-9701CE428811}"/>
               </a:ext>
             </a:extLst>
           </p:cNvPr>
@@ -7150,7 +7150,7 @@
           <p:cNvPr id="15" name="">
             <a:extLst xmlns:a="http://schemas.openxmlformats.org/drawingml/2006/main">
               <a:ext uri="{FF2B5EF4-FFF2-40B4-BE49-F238E27FC236}">
-                <a16:creationId xmlns:a16="http://schemas.microsoft.com/office/drawing/2014/main" id="{8BD48485-17CD-475A-8F0F-B400C50C5122}"/>
+                <a16:creationId xmlns:a16="http://schemas.microsoft.com/office/drawing/2014/main" id="{2E1803F5-7FE4-4E25-A4CD-37F7E1A5BC7A}"/>
               </a:ext>
             </a:extLst>
           </p:cNvPr>
@@ -7200,7 +7200,7 @@
           <p:cNvPr id="16" name="">
             <a:extLst xmlns:a="http://schemas.openxmlformats.org/drawingml/2006/main">
               <a:ext uri="{FF2B5EF4-FFF2-40B4-BE49-F238E27FC236}">
-                <a16:creationId xmlns:a16="http://schemas.microsoft.com/office/drawing/2014/main" id="{2F5DDF23-A853-411C-B60C-40A7681BA0F7}"/>
+                <a16:creationId xmlns:a16="http://schemas.microsoft.com/office/drawing/2014/main" id="{52DA80D4-DCF0-4BB9-9CF1-A241CE4B5A25}"/>
               </a:ext>
             </a:extLst>
           </p:cNvPr>
@@ -7250,7 +7250,7 @@
           <p:cNvPr id="17" name="">
             <a:extLst xmlns:a="http://schemas.openxmlformats.org/drawingml/2006/main">
               <a:ext uri="{FF2B5EF4-FFF2-40B4-BE49-F238E27FC236}">
-                <a16:creationId xmlns:a16="http://schemas.microsoft.com/office/drawing/2014/main" id="{CEDEF890-6691-479B-BAB0-DF530DF87850}"/>
+                <a16:creationId xmlns:a16="http://schemas.microsoft.com/office/drawing/2014/main" id="{65FE2F17-5AC5-4749-A7E2-03BB188B4D05}"/>
               </a:ext>
             </a:extLst>
           </p:cNvPr>
@@ -7298,7 +7298,7 @@
     </p:spTree>
     <p:extLst>
       <p:ext uri="{BB962C8B-B14F-4D97-AF65-F5344CB8AC3E}">
-        <p14:creationId xmlns:p14="http://schemas.microsoft.com/office/powerpoint/2010/main" val="132415116"/>
+        <p14:creationId xmlns:p14="http://schemas.microsoft.com/office/powerpoint/2010/main" val="1284611089"/>
       </p:ext>
     </p:extLst>
   </p:cSld>
@@ -7322,7 +7322,7 @@
           <p:cNvPr id="1" name="">
             <a:extLst xmlns:a="http://schemas.openxmlformats.org/drawingml/2006/main">
               <a:ext uri="{FF2B5EF4-FFF2-40B4-BE49-F238E27FC236}">
-                <a16:creationId xmlns:a16="http://schemas.microsoft.com/office/drawing/2014/main" id="{D4668001-3351-4E2B-9DA6-42977A48BCEA}"/>
+                <a16:creationId xmlns:a16="http://schemas.microsoft.com/office/drawing/2014/main" id="{AF744873-DFCF-4085-89BC-2C065056FEC1}"/>
               </a:ext>
             </a:extLst>
           </p:cNvPr>
@@ -7372,7 +7372,7 @@
           <p:cNvPr id="2" name="">
             <a:extLst xmlns:a="http://schemas.openxmlformats.org/drawingml/2006/main">
               <a:ext uri="{FF2B5EF4-FFF2-40B4-BE49-F238E27FC236}">
-                <a16:creationId xmlns:a16="http://schemas.microsoft.com/office/drawing/2014/main" id="{5FDB7336-3BF6-449E-98F8-FC573618697B}"/>
+                <a16:creationId xmlns:a16="http://schemas.microsoft.com/office/drawing/2014/main" id="{76D0B913-6249-42EE-8F00-DBF966E94832}"/>
               </a:ext>
             </a:extLst>
           </p:cNvPr>
@@ -7422,7 +7422,7 @@
           <p:cNvPr id="3" name="">
             <a:extLst xmlns:a="http://schemas.openxmlformats.org/drawingml/2006/main">
               <a:ext uri="{FF2B5EF4-FFF2-40B4-BE49-F238E27FC236}">
-                <a16:creationId xmlns:a16="http://schemas.microsoft.com/office/drawing/2014/main" id="{94894A3F-CB89-4389-9FEE-96F458A7864A}"/>
+                <a16:creationId xmlns:a16="http://schemas.microsoft.com/office/drawing/2014/main" id="{873FDBD5-EAEB-4C8C-9AAB-CBBF4A6C0F31}"/>
               </a:ext>
             </a:extLst>
           </p:cNvPr>
@@ -7455,7 +7455,7 @@
           <p:cNvPr id="4" name="">
             <a:extLst xmlns:a="http://schemas.openxmlformats.org/drawingml/2006/main">
               <a:ext uri="{FF2B5EF4-FFF2-40B4-BE49-F238E27FC236}">
-                <a16:creationId xmlns:a16="http://schemas.microsoft.com/office/drawing/2014/main" id="{30C038BA-7651-48CC-A15D-235EB94873F4}"/>
+                <a16:creationId xmlns:a16="http://schemas.microsoft.com/office/drawing/2014/main" id="{F32B4694-B61B-49EC-B200-1E9780ED1960}"/>
               </a:ext>
             </a:extLst>
           </p:cNvPr>
@@ -7505,7 +7505,7 @@
           <p:cNvPr id="5" name="">
             <a:extLst xmlns:a="http://schemas.openxmlformats.org/drawingml/2006/main">
               <a:ext uri="{FF2B5EF4-FFF2-40B4-BE49-F238E27FC236}">
-                <a16:creationId xmlns:a16="http://schemas.microsoft.com/office/drawing/2014/main" id="{09AB790F-8592-40AE-829D-462D83B9B304}"/>
+                <a16:creationId xmlns:a16="http://schemas.microsoft.com/office/drawing/2014/main" id="{63E39759-DADE-4B39-9118-1209F6EBC733}"/>
               </a:ext>
             </a:extLst>
           </p:cNvPr>
@@ -7536,7 +7536,7 @@
           <p:cNvPr id="6" name="">
             <a:extLst xmlns:a="http://schemas.openxmlformats.org/drawingml/2006/main">
               <a:ext uri="{FF2B5EF4-FFF2-40B4-BE49-F238E27FC236}">
-                <a16:creationId xmlns:a16="http://schemas.microsoft.com/office/drawing/2014/main" id="{DC7729AC-CC2D-4C40-B03C-BB7E64D84A6B}"/>
+                <a16:creationId xmlns:a16="http://schemas.microsoft.com/office/drawing/2014/main" id="{79A78E15-FA7F-41C0-9AB2-6DBEA3FE729E}"/>
               </a:ext>
             </a:extLst>
           </p:cNvPr>
@@ -7586,7 +7586,7 @@
           <p:cNvPr id="7" name="">
             <a:extLst xmlns:a="http://schemas.openxmlformats.org/drawingml/2006/main">
               <a:ext uri="{FF2B5EF4-FFF2-40B4-BE49-F238E27FC236}">
-                <a16:creationId xmlns:a16="http://schemas.microsoft.com/office/drawing/2014/main" id="{AD21067F-6B1A-4547-8C8C-5B958056E1A7}"/>
+                <a16:creationId xmlns:a16="http://schemas.microsoft.com/office/drawing/2014/main" id="{A911C923-531D-4675-9382-087FDFFA351B}"/>
               </a:ext>
             </a:extLst>
           </p:cNvPr>
@@ -7670,7 +7670,7 @@
           <p:cNvPr id="8" name="">
             <a:extLst xmlns:a="http://schemas.openxmlformats.org/drawingml/2006/main">
               <a:ext uri="{FF2B5EF4-FFF2-40B4-BE49-F238E27FC236}">
-                <a16:creationId xmlns:a16="http://schemas.microsoft.com/office/drawing/2014/main" id="{84831EB0-30E0-4513-BC7A-7FF7E149F132}"/>
+                <a16:creationId xmlns:a16="http://schemas.microsoft.com/office/drawing/2014/main" id="{275F5934-4864-42B0-8344-F2FDDF4952BF}"/>
               </a:ext>
             </a:extLst>
           </p:cNvPr>
@@ -7701,7 +7701,7 @@
           <p:cNvPr id="9" name="">
             <a:extLst xmlns:a="http://schemas.openxmlformats.org/drawingml/2006/main">
               <a:ext uri="{FF2B5EF4-FFF2-40B4-BE49-F238E27FC236}">
-                <a16:creationId xmlns:a16="http://schemas.microsoft.com/office/drawing/2014/main" id="{3126AA26-ECC8-4E1A-8BD9-11ED5DF3CDF8}"/>
+                <a16:creationId xmlns:a16="http://schemas.microsoft.com/office/drawing/2014/main" id="{F5A2288E-9D86-4185-807A-A9680AD7A91B}"/>
               </a:ext>
             </a:extLst>
           </p:cNvPr>
@@ -7751,7 +7751,7 @@
           <p:cNvPr id="10" name="">
             <a:extLst xmlns:a="http://schemas.openxmlformats.org/drawingml/2006/main">
               <a:ext uri="{FF2B5EF4-FFF2-40B4-BE49-F238E27FC236}">
-                <a16:creationId xmlns:a16="http://schemas.microsoft.com/office/drawing/2014/main" id="{568A22E3-ED35-454E-BD60-43B429272A22}"/>
+                <a16:creationId xmlns:a16="http://schemas.microsoft.com/office/drawing/2014/main" id="{C9CE2771-4620-48EC-A6AB-4D0EF3B68F03}"/>
               </a:ext>
             </a:extLst>
           </p:cNvPr>
@@ -7835,7 +7835,7 @@
           <p:cNvPr id="11" name="">
             <a:extLst xmlns:a="http://schemas.openxmlformats.org/drawingml/2006/main">
               <a:ext uri="{FF2B5EF4-FFF2-40B4-BE49-F238E27FC236}">
-                <a16:creationId xmlns:a16="http://schemas.microsoft.com/office/drawing/2014/main" id="{CC14A0AA-2FED-4981-A047-F4E9BDB852FD}"/>
+                <a16:creationId xmlns:a16="http://schemas.microsoft.com/office/drawing/2014/main" id="{F2C8B36F-6623-4212-9454-45BB95449998}"/>
               </a:ext>
             </a:extLst>
           </p:cNvPr>
@@ -7866,7 +7866,7 @@
           <p:cNvPr id="12" name="">
             <a:extLst xmlns:a="http://schemas.openxmlformats.org/drawingml/2006/main">
               <a:ext uri="{FF2B5EF4-FFF2-40B4-BE49-F238E27FC236}">
-                <a16:creationId xmlns:a16="http://schemas.microsoft.com/office/drawing/2014/main" id="{0FCCD8D2-2984-44D7-A29A-F739661C0F1E}"/>
+                <a16:creationId xmlns:a16="http://schemas.microsoft.com/office/drawing/2014/main" id="{77F1E9C2-2471-441B-8AB1-D9A7B98DE54A}"/>
               </a:ext>
             </a:extLst>
           </p:cNvPr>
@@ -7916,7 +7916,7 @@
           <p:cNvPr id="13" name="">
             <a:extLst xmlns:a="http://schemas.openxmlformats.org/drawingml/2006/main">
               <a:ext uri="{FF2B5EF4-FFF2-40B4-BE49-F238E27FC236}">
-                <a16:creationId xmlns:a16="http://schemas.microsoft.com/office/drawing/2014/main" id="{28A17AD8-2621-4953-BDA2-5A9FF1482941}"/>
+                <a16:creationId xmlns:a16="http://schemas.microsoft.com/office/drawing/2014/main" id="{A5C4783F-B2D5-4B9E-9221-218F40B01CB3}"/>
               </a:ext>
             </a:extLst>
           </p:cNvPr>
@@ -8000,7 +8000,7 @@
           <p:cNvPr id="14" name="">
             <a:extLst xmlns:a="http://schemas.openxmlformats.org/drawingml/2006/main">
               <a:ext uri="{FF2B5EF4-FFF2-40B4-BE49-F238E27FC236}">
-                <a16:creationId xmlns:a16="http://schemas.microsoft.com/office/drawing/2014/main" id="{C75F2B12-9661-4733-B315-E445E645C466}"/>
+                <a16:creationId xmlns:a16="http://schemas.microsoft.com/office/drawing/2014/main" id="{E09632E0-0BBB-4CE9-9981-AEAAF7127AC5}"/>
               </a:ext>
             </a:extLst>
           </p:cNvPr>
@@ -8050,7 +8050,7 @@
           <p:cNvPr id="15" name="">
             <a:extLst xmlns:a="http://schemas.openxmlformats.org/drawingml/2006/main">
               <a:ext uri="{FF2B5EF4-FFF2-40B4-BE49-F238E27FC236}">
-                <a16:creationId xmlns:a16="http://schemas.microsoft.com/office/drawing/2014/main" id="{2F4A9BB5-CF06-4E27-8B21-1D45FE8F8FB4}"/>
+                <a16:creationId xmlns:a16="http://schemas.microsoft.com/office/drawing/2014/main" id="{7F333CC9-0FC8-4D2A-9F97-AC9A9DDFBD69}"/>
               </a:ext>
             </a:extLst>
           </p:cNvPr>
@@ -8098,7 +8098,7 @@
     </p:spTree>
     <p:extLst>
       <p:ext uri="{BB962C8B-B14F-4D97-AF65-F5344CB8AC3E}">
-        <p14:creationId xmlns:p14="http://schemas.microsoft.com/office/powerpoint/2010/main" val="622083991"/>
+        <p14:creationId xmlns:p14="http://schemas.microsoft.com/office/powerpoint/2010/main" val="361596863"/>
       </p:ext>
     </p:extLst>
   </p:cSld>
@@ -8122,7 +8122,7 @@
           <p:cNvPr id="1" name="">
             <a:extLst xmlns:a="http://schemas.openxmlformats.org/drawingml/2006/main">
               <a:ext uri="{FF2B5EF4-FFF2-40B4-BE49-F238E27FC236}">
-                <a16:creationId xmlns:a16="http://schemas.microsoft.com/office/drawing/2014/main" id="{0F44EE02-A237-4FF5-901C-B3CA56CA9723}"/>
+                <a16:creationId xmlns:a16="http://schemas.microsoft.com/office/drawing/2014/main" id="{484F5884-B9F8-410F-BAB0-B71B4A0F1315}"/>
               </a:ext>
             </a:extLst>
           </p:cNvPr>
@@ -8172,7 +8172,7 @@
           <p:cNvPr id="2" name="">
             <a:extLst xmlns:a="http://schemas.openxmlformats.org/drawingml/2006/main">
               <a:ext uri="{FF2B5EF4-FFF2-40B4-BE49-F238E27FC236}">
-                <a16:creationId xmlns:a16="http://schemas.microsoft.com/office/drawing/2014/main" id="{344CE53E-4681-42B4-A624-B25A848E70FA}"/>
+                <a16:creationId xmlns:a16="http://schemas.microsoft.com/office/drawing/2014/main" id="{0DFFAFC4-4B3E-4EB3-AF1D-17B978FD99A8}"/>
               </a:ext>
             </a:extLst>
           </p:cNvPr>
@@ -8222,7 +8222,7 @@
           <p:cNvPr id="3" name="">
             <a:extLst xmlns:a="http://schemas.openxmlformats.org/drawingml/2006/main">
               <a:ext uri="{FF2B5EF4-FFF2-40B4-BE49-F238E27FC236}">
-                <a16:creationId xmlns:a16="http://schemas.microsoft.com/office/drawing/2014/main" id="{0253BE93-4640-47C6-B464-997EE1CB6451}"/>
+                <a16:creationId xmlns:a16="http://schemas.microsoft.com/office/drawing/2014/main" id="{E3E4CCF2-3D3C-402F-BE5B-E8B79FC98011}"/>
               </a:ext>
             </a:extLst>
           </p:cNvPr>
@@ -8255,7 +8255,7 @@
           <p:cNvPr id="4" name="">
             <a:extLst xmlns:a="http://schemas.openxmlformats.org/drawingml/2006/main">
               <a:ext uri="{FF2B5EF4-FFF2-40B4-BE49-F238E27FC236}">
-                <a16:creationId xmlns:a16="http://schemas.microsoft.com/office/drawing/2014/main" id="{0AE82BC8-71AA-4CB1-AB84-9030D6419058}"/>
+                <a16:creationId xmlns:a16="http://schemas.microsoft.com/office/drawing/2014/main" id="{C69236DD-F8D6-47CF-8655-F75050109D4B}"/>
               </a:ext>
             </a:extLst>
           </p:cNvPr>
@@ -8305,7 +8305,7 @@
           <p:cNvPr id="5" name="">
             <a:extLst xmlns:a="http://schemas.openxmlformats.org/drawingml/2006/main">
               <a:ext uri="{FF2B5EF4-FFF2-40B4-BE49-F238E27FC236}">
-                <a16:creationId xmlns:a16="http://schemas.microsoft.com/office/drawing/2014/main" id="{49A5591C-693D-448E-9F01-7F2A6261D57A}"/>
+                <a16:creationId xmlns:a16="http://schemas.microsoft.com/office/drawing/2014/main" id="{48E22F6B-D3A4-4580-BEC9-1AC2EE07533E}"/>
               </a:ext>
             </a:extLst>
           </p:cNvPr>
@@ -8440,7 +8440,7 @@
           <p:cNvPr id="6" name="">
             <a:extLst xmlns:a="http://schemas.openxmlformats.org/drawingml/2006/main">
               <a:ext uri="{FF2B5EF4-FFF2-40B4-BE49-F238E27FC236}">
-                <a16:creationId xmlns:a16="http://schemas.microsoft.com/office/drawing/2014/main" id="{FC3F0320-5CFF-42AE-891E-5B6BDCEF63AB}"/>
+                <a16:creationId xmlns:a16="http://schemas.microsoft.com/office/drawing/2014/main" id="{BE3F85CC-C229-419D-9E2A-E0904DD13EFA}"/>
               </a:ext>
             </a:extLst>
           </p:cNvPr>
@@ -8471,7 +8471,7 @@
           <p:cNvPr id="7" name="">
             <a:extLst xmlns:a="http://schemas.openxmlformats.org/drawingml/2006/main">
               <a:ext uri="{FF2B5EF4-FFF2-40B4-BE49-F238E27FC236}">
-                <a16:creationId xmlns:a16="http://schemas.microsoft.com/office/drawing/2014/main" id="{C3246CEF-41F9-43E3-97F2-08D85C1838F1}"/>
+                <a16:creationId xmlns:a16="http://schemas.microsoft.com/office/drawing/2014/main" id="{0BCA0C83-8A0C-4142-BA8C-4CB77D7D3914}"/>
               </a:ext>
             </a:extLst>
           </p:cNvPr>
@@ -8572,7 +8572,7 @@
           <p:cNvPr id="8" name="">
             <a:extLst xmlns:a="http://schemas.openxmlformats.org/drawingml/2006/main">
               <a:ext uri="{FF2B5EF4-FFF2-40B4-BE49-F238E27FC236}">
-                <a16:creationId xmlns:a16="http://schemas.microsoft.com/office/drawing/2014/main" id="{1A9ED0A5-542A-460F-98F5-F530E19CB197}"/>
+                <a16:creationId xmlns:a16="http://schemas.microsoft.com/office/drawing/2014/main" id="{E2C8E1AF-882E-4101-9A0F-81069D299476}"/>
               </a:ext>
             </a:extLst>
           </p:cNvPr>
@@ -8622,7 +8622,7 @@
           <p:cNvPr id="9" name="">
             <a:extLst xmlns:a="http://schemas.openxmlformats.org/drawingml/2006/main">
               <a:ext uri="{FF2B5EF4-FFF2-40B4-BE49-F238E27FC236}">
-                <a16:creationId xmlns:a16="http://schemas.microsoft.com/office/drawing/2014/main" id="{B3F96AD7-B9C4-4CD7-9631-5A45F5A02DAB}"/>
+                <a16:creationId xmlns:a16="http://schemas.microsoft.com/office/drawing/2014/main" id="{7F1BEF58-CF88-4D2B-A726-3EC1E30C87A7}"/>
               </a:ext>
             </a:extLst>
           </p:cNvPr>
@@ -8670,7 +8670,7 @@
     </p:spTree>
     <p:extLst>
       <p:ext uri="{BB962C8B-B14F-4D97-AF65-F5344CB8AC3E}">
-        <p14:creationId xmlns:p14="http://schemas.microsoft.com/office/powerpoint/2010/main" val="67429709"/>
+        <p14:creationId xmlns:p14="http://schemas.microsoft.com/office/powerpoint/2010/main" val="693484000"/>
       </p:ext>
     </p:extLst>
   </p:cSld>

</xml_diff>

<commit_message>
Add detailed defense and auditor materials
</commit_message>
<xml_diff>
--- a/Professional_Industry_Defense_Deck.pptx
+++ b/Professional_Industry_Defense_Deck.pptx
@@ -262,9 +262,9 @@
 </file>
 
 <file path=ppt/notesMasters/theme/theme3.xml><?xml version="1.0" encoding="utf-8"?>
-<a:theme xmlns:a="http://schemas.openxmlformats.org/drawingml/2006/main" name="ChatGPT">
+<a:theme xmlns:a="http://schemas.openxmlformats.org/drawingml/2006/main" name="SukhSandhu">
   <a:themeElements>
-    <a:clrScheme name="ChatGPT">
+    <a:clrScheme name="SukhSandhu">
       <a:dk1>
         <a:srgbClr val="000000"/>
       </a:dk1>
@@ -314,7 +314,7 @@
         <a:cs typeface="Calibri"/>
       </a:minorFont>
     </a:fontScheme>
-    <a:fmtScheme name="ChatGPT">
+    <a:fmtScheme name="SukhSandhu">
       <a:fillStyleLst>
         <a:solidFill>
           <a:schemeClr val="phClr"/>
@@ -1627,9 +1627,9 @@
 </file>
 
 <file path=ppt/slideMasters/theme/theme2.xml><?xml version="1.0" encoding="utf-8"?>
-<a:theme xmlns:a="http://schemas.openxmlformats.org/drawingml/2006/main" name="ChatGPT">
+<a:theme xmlns:a="http://schemas.openxmlformats.org/drawingml/2006/main" name="SukhSandhu">
   <a:themeElements>
-    <a:clrScheme name="ChatGPT">
+    <a:clrScheme name="SukhSandhu">
       <a:dk1>
         <a:srgbClr val="000000"/>
       </a:dk1>
@@ -1679,7 +1679,7 @@
         <a:cs typeface="Calibri"/>
       </a:minorFont>
     </a:fontScheme>
-    <a:fmtScheme name="ChatGPT">
+    <a:fmtScheme name="SukhSandhu">
       <a:fillStyleLst>
         <a:solidFill>
           <a:schemeClr val="phClr"/>
@@ -8678,9 +8678,9 @@
 </file>
 
 <file path=ppt/theme/theme1.xml><?xml version="1.0" encoding="utf-8"?>
-<a:theme xmlns:a="http://schemas.openxmlformats.org/drawingml/2006/main" name="ChatGPT">
+<a:theme xmlns:a="http://schemas.openxmlformats.org/drawingml/2006/main" name="SukhSandhu">
   <a:themeElements>
-    <a:clrScheme name="ChatGPT">
+    <a:clrScheme name="SukhSandhu">
       <a:dk1>
         <a:srgbClr val="000000"/>
       </a:dk1>
@@ -8730,7 +8730,7 @@
         <a:cs typeface="Calibri"/>
       </a:minorFont>
     </a:fontScheme>
-    <a:fmtScheme name="ChatGPT">
+    <a:fmtScheme name="SukhSandhu">
       <a:fillStyleLst>
         <a:solidFill>
           <a:schemeClr val="phClr"/>

</xml_diff>